<commit_message>
docs(showcase): fix slide 7 (KNOCK JSON overflow) + slide 11 (runtime tiles cropped)
Visual QA caught two layout bugs in the first render:

- Slide 7 (MESH/KNOCK frame): JSON code block was 17 lines @ fontSize 12
  in a 2.9" panel — closing braces overflowed below the gray panel.
  Fixed: shrunk to fontSize 11, panel taller (3.55"), raised to y:3.85
  to use the available space without colliding with the lede.

- Slide 11 (RUNTIMES): 4 tiles @ 3.85" wide + 0.15" gaps = 15.85"
  total, but the slide is only 13.3" wide — x0 went negative,
  cropping leftmost tiles. Fixed: tw=2.9" → 12.25" total, centred
  with 0.525" left/right margin.

Re-rendered all 15 slides, visual QA pass clean across the board.

Co-authored-by: Copilot <223556219+Copilot@users.noreply.github.com>
</commit_message>
<xml_diff>
--- a/docs/showcase/deliverables/kars-pitch-deck.pptx
+++ b/docs/showcase/deliverables/kars-pitch-deck.pptx
@@ -3714,8 +3714,8 @@
         </p:nvSpPr>
         <p:spPr>
           <a:xfrm>
-            <a:off x="-1165860" y="3657600"/>
-            <a:ext cx="3520440" cy="914400"/>
+            <a:off x="571500" y="3657600"/>
+            <a:ext cx="2651760" cy="914400"/>
           </a:xfrm>
           <a:prstGeom prst="rect">
             <a:avLst/>
@@ -3739,8 +3739,8 @@
         </p:nvSpPr>
         <p:spPr>
           <a:xfrm>
-            <a:off x="-982980" y="3794760"/>
-            <a:ext cx="3154680" cy="365760"/>
+            <a:off x="754380" y="3794760"/>
+            <a:ext cx="2286000" cy="365760"/>
           </a:xfrm>
           <a:prstGeom prst="rect">
             <a:avLst/>
@@ -3778,8 +3778,8 @@
         </p:nvSpPr>
         <p:spPr>
           <a:xfrm>
-            <a:off x="-982980" y="4160520"/>
-            <a:ext cx="3154680" cy="365760"/>
+            <a:off x="754380" y="4160520"/>
+            <a:ext cx="2286000" cy="365760"/>
           </a:xfrm>
           <a:prstGeom prst="rect">
             <a:avLst/>
@@ -3817,8 +3817,8 @@
         </p:nvSpPr>
         <p:spPr>
           <a:xfrm>
-            <a:off x="2491740" y="3657600"/>
-            <a:ext cx="3520440" cy="914400"/>
+            <a:off x="3360420" y="3657600"/>
+            <a:ext cx="2651760" cy="914400"/>
           </a:xfrm>
           <a:prstGeom prst="rect">
             <a:avLst/>
@@ -3842,8 +3842,8 @@
         </p:nvSpPr>
         <p:spPr>
           <a:xfrm>
-            <a:off x="2674620" y="3794760"/>
-            <a:ext cx="3154680" cy="365760"/>
+            <a:off x="3543300" y="3794760"/>
+            <a:ext cx="2286000" cy="365760"/>
           </a:xfrm>
           <a:prstGeom prst="rect">
             <a:avLst/>
@@ -3881,8 +3881,8 @@
         </p:nvSpPr>
         <p:spPr>
           <a:xfrm>
-            <a:off x="2674620" y="4160520"/>
-            <a:ext cx="3154680" cy="365760"/>
+            <a:off x="3543300" y="4160520"/>
+            <a:ext cx="2286000" cy="365760"/>
           </a:xfrm>
           <a:prstGeom prst="rect">
             <a:avLst/>
@@ -3921,7 +3921,7 @@
         <p:spPr>
           <a:xfrm>
             <a:off x="6149340" y="3657600"/>
-            <a:ext cx="3520440" cy="914400"/>
+            <a:ext cx="2651760" cy="914400"/>
           </a:xfrm>
           <a:prstGeom prst="rect">
             <a:avLst/>
@@ -3946,7 +3946,7 @@
         <p:spPr>
           <a:xfrm>
             <a:off x="6332220" y="3794760"/>
-            <a:ext cx="3154680" cy="365760"/>
+            <a:ext cx="2286000" cy="365760"/>
           </a:xfrm>
           <a:prstGeom prst="rect">
             <a:avLst/>
@@ -3985,7 +3985,7 @@
         <p:spPr>
           <a:xfrm>
             <a:off x="6332220" y="4160520"/>
-            <a:ext cx="3154680" cy="365760"/>
+            <a:ext cx="2286000" cy="365760"/>
           </a:xfrm>
           <a:prstGeom prst="rect">
             <a:avLst/>
@@ -4023,8 +4023,8 @@
         </p:nvSpPr>
         <p:spPr>
           <a:xfrm>
-            <a:off x="9806940" y="3657600"/>
-            <a:ext cx="3520440" cy="914400"/>
+            <a:off x="8938260" y="3657600"/>
+            <a:ext cx="2651760" cy="914400"/>
           </a:xfrm>
           <a:prstGeom prst="rect">
             <a:avLst/>
@@ -4048,8 +4048,8 @@
         </p:nvSpPr>
         <p:spPr>
           <a:xfrm>
-            <a:off x="9989820" y="3794760"/>
-            <a:ext cx="3154680" cy="365760"/>
+            <a:off x="9121140" y="3794760"/>
+            <a:ext cx="2286000" cy="365760"/>
           </a:xfrm>
           <a:prstGeom prst="rect">
             <a:avLst/>
@@ -4087,8 +4087,8 @@
         </p:nvSpPr>
         <p:spPr>
           <a:xfrm>
-            <a:off x="9989820" y="4160520"/>
-            <a:ext cx="3154680" cy="365760"/>
+            <a:off x="9121140" y="4160520"/>
+            <a:ext cx="2286000" cy="365760"/>
           </a:xfrm>
           <a:prstGeom prst="rect">
             <a:avLst/>
@@ -4126,8 +4126,8 @@
         </p:nvSpPr>
         <p:spPr>
           <a:xfrm>
-            <a:off x="-1165860" y="4709160"/>
-            <a:ext cx="3520440" cy="914400"/>
+            <a:off x="571500" y="4709160"/>
+            <a:ext cx="2651760" cy="914400"/>
           </a:xfrm>
           <a:prstGeom prst="rect">
             <a:avLst/>
@@ -4151,8 +4151,8 @@
         </p:nvSpPr>
         <p:spPr>
           <a:xfrm>
-            <a:off x="-982980" y="4846320"/>
-            <a:ext cx="3154680" cy="365760"/>
+            <a:off x="754380" y="4846320"/>
+            <a:ext cx="2286000" cy="365760"/>
           </a:xfrm>
           <a:prstGeom prst="rect">
             <a:avLst/>
@@ -4190,8 +4190,8 @@
         </p:nvSpPr>
         <p:spPr>
           <a:xfrm>
-            <a:off x="-982980" y="5212080"/>
-            <a:ext cx="3154680" cy="365760"/>
+            <a:off x="754380" y="5212080"/>
+            <a:ext cx="2286000" cy="365760"/>
           </a:xfrm>
           <a:prstGeom prst="rect">
             <a:avLst/>
@@ -4229,8 +4229,8 @@
         </p:nvSpPr>
         <p:spPr>
           <a:xfrm>
-            <a:off x="2491740" y="4709160"/>
-            <a:ext cx="3520440" cy="914400"/>
+            <a:off x="3360420" y="4709160"/>
+            <a:ext cx="2651760" cy="914400"/>
           </a:xfrm>
           <a:prstGeom prst="rect">
             <a:avLst/>
@@ -4254,8 +4254,8 @@
         </p:nvSpPr>
         <p:spPr>
           <a:xfrm>
-            <a:off x="2674620" y="4846320"/>
-            <a:ext cx="3154680" cy="365760"/>
+            <a:off x="3543300" y="4846320"/>
+            <a:ext cx="2286000" cy="365760"/>
           </a:xfrm>
           <a:prstGeom prst="rect">
             <a:avLst/>
@@ -4293,8 +4293,8 @@
         </p:nvSpPr>
         <p:spPr>
           <a:xfrm>
-            <a:off x="2674620" y="5212080"/>
-            <a:ext cx="3154680" cy="365760"/>
+            <a:off x="3543300" y="5212080"/>
+            <a:ext cx="2286000" cy="365760"/>
           </a:xfrm>
           <a:prstGeom prst="rect">
             <a:avLst/>
@@ -4333,7 +4333,7 @@
         <p:spPr>
           <a:xfrm>
             <a:off x="6149340" y="4709160"/>
-            <a:ext cx="3520440" cy="914400"/>
+            <a:ext cx="2651760" cy="914400"/>
           </a:xfrm>
           <a:prstGeom prst="rect">
             <a:avLst/>
@@ -4358,7 +4358,7 @@
         <p:spPr>
           <a:xfrm>
             <a:off x="6332220" y="4846320"/>
-            <a:ext cx="3154680" cy="365760"/>
+            <a:ext cx="2286000" cy="365760"/>
           </a:xfrm>
           <a:prstGeom prst="rect">
             <a:avLst/>
@@ -4397,7 +4397,7 @@
         <p:spPr>
           <a:xfrm>
             <a:off x="6332220" y="5212080"/>
-            <a:ext cx="3154680" cy="365760"/>
+            <a:ext cx="2286000" cy="365760"/>
           </a:xfrm>
           <a:prstGeom prst="rect">
             <a:avLst/>
@@ -4435,8 +4435,8 @@
         </p:nvSpPr>
         <p:spPr>
           <a:xfrm>
-            <a:off x="9806940" y="4709160"/>
-            <a:ext cx="3520440" cy="914400"/>
+            <a:off x="8938260" y="4709160"/>
+            <a:ext cx="2651760" cy="914400"/>
           </a:xfrm>
           <a:prstGeom prst="rect">
             <a:avLst/>
@@ -4460,8 +4460,8 @@
         </p:nvSpPr>
         <p:spPr>
           <a:xfrm>
-            <a:off x="9989820" y="4846320"/>
-            <a:ext cx="3154680" cy="365760"/>
+            <a:off x="9121140" y="4846320"/>
+            <a:ext cx="2286000" cy="365760"/>
           </a:xfrm>
           <a:prstGeom prst="rect">
             <a:avLst/>
@@ -4499,8 +4499,8 @@
         </p:nvSpPr>
         <p:spPr>
           <a:xfrm>
-            <a:off x="9989820" y="5212080"/>
-            <a:ext cx="3154680" cy="365760"/>
+            <a:off x="9121140" y="5212080"/>
+            <a:ext cx="2286000" cy="365760"/>
           </a:xfrm>
           <a:prstGeom prst="rect">
             <a:avLst/>
@@ -9064,8 +9064,8 @@
         </p:nvSpPr>
         <p:spPr>
           <a:xfrm>
-            <a:off x="640080" y="3657600"/>
-            <a:ext cx="6035040" cy="2651760"/>
+            <a:off x="640080" y="3520440"/>
+            <a:ext cx="6035040" cy="3246120"/>
           </a:xfrm>
           <a:prstGeom prst="rect">
             <a:avLst/>
@@ -9089,8 +9089,8 @@
         </p:nvSpPr>
         <p:spPr>
           <a:xfrm>
-            <a:off x="868680" y="3886200"/>
-            <a:ext cx="5577840" cy="2194560"/>
+            <a:off x="868680" y="3749040"/>
+            <a:ext cx="5577840" cy="2788920"/>
           </a:xfrm>
           <a:prstGeom prst="rect">
             <a:avLst/>
@@ -9106,7 +9106,7 @@
               <a:buNone/>
             </a:pPr>
             <a:r>
-              <a:rPr lang="en-US" sz="1200" dirty="0">
+              <a:rPr lang="en-US" sz="1100" dirty="0">
                 <a:solidFill>
                   <a:srgbClr val="1A1A1A"/>
                 </a:solidFill>
@@ -9121,7 +9121,7 @@
               <a:buNone/>
             </a:pPr>
             <a:r>
-              <a:rPr lang="en-US" sz="1200" dirty="0">
+              <a:rPr lang="en-US" sz="1100" dirty="0">
                 <a:solidFill>
                   <a:srgbClr val="C53030"/>
                 </a:solidFill>
@@ -9135,7 +9135,7 @@
               <a:buNone/>
             </a:pPr>
             <a:r>
-              <a:rPr lang="en-US" sz="1200" dirty="0">
+              <a:rPr lang="en-US" sz="1100" dirty="0">
                 <a:solidFill>
                   <a:srgbClr val="276749"/>
                 </a:solidFill>
@@ -9150,7 +9150,7 @@
               <a:buNone/>
             </a:pPr>
             <a:r>
-              <a:rPr lang="en-US" sz="1200" dirty="0">
+              <a:rPr lang="en-US" sz="1100" dirty="0">
                 <a:solidFill>
                   <a:srgbClr val="C53030"/>
                 </a:solidFill>
@@ -9164,7 +9164,7 @@
               <a:buNone/>
             </a:pPr>
             <a:r>
-              <a:rPr lang="en-US" sz="1200" dirty="0">
+              <a:rPr lang="en-US" sz="1100" dirty="0">
                 <a:solidFill>
                   <a:srgbClr val="276749"/>
                 </a:solidFill>
@@ -9179,7 +9179,7 @@
               <a:buNone/>
             </a:pPr>
             <a:r>
-              <a:rPr lang="en-US" sz="1200" dirty="0">
+              <a:rPr lang="en-US" sz="1100" dirty="0">
                 <a:solidFill>
                   <a:srgbClr val="C53030"/>
                 </a:solidFill>
@@ -9193,7 +9193,7 @@
               <a:buNone/>
             </a:pPr>
             <a:r>
-              <a:rPr lang="en-US" sz="1200" dirty="0">
+              <a:rPr lang="en-US" sz="1100" dirty="0">
                 <a:solidFill>
                   <a:srgbClr val="276749"/>
                 </a:solidFill>
@@ -9208,7 +9208,7 @@
               <a:buNone/>
             </a:pPr>
             <a:r>
-              <a:rPr lang="en-US" sz="1200" dirty="0">
+              <a:rPr lang="en-US" sz="1100" dirty="0">
                 <a:solidFill>
                   <a:srgbClr val="C53030"/>
                 </a:solidFill>
@@ -9222,7 +9222,7 @@
               <a:buNone/>
             </a:pPr>
             <a:r>
-              <a:rPr lang="en-US" sz="1200" dirty="0">
+              <a:rPr lang="en-US" sz="1100" dirty="0">
                 <a:solidFill>
                   <a:srgbClr val="276749"/>
                 </a:solidFill>
@@ -9237,7 +9237,7 @@
               <a:buNone/>
             </a:pPr>
             <a:r>
-              <a:rPr lang="en-US" sz="1200" dirty="0">
+              <a:rPr lang="en-US" sz="1100" dirty="0">
                 <a:solidFill>
                   <a:srgbClr val="C53030"/>
                 </a:solidFill>
@@ -9251,7 +9251,7 @@
               <a:buNone/>
             </a:pPr>
             <a:r>
-              <a:rPr lang="en-US" sz="1200" dirty="0">
+              <a:rPr lang="en-US" sz="1100" dirty="0">
                 <a:solidFill>
                   <a:srgbClr val="276749"/>
                 </a:solidFill>
@@ -9266,7 +9266,7 @@
               <a:buNone/>
             </a:pPr>
             <a:r>
-              <a:rPr lang="en-US" sz="1200" dirty="0">
+              <a:rPr lang="en-US" sz="1100" dirty="0">
                 <a:solidFill>
                   <a:srgbClr val="C53030"/>
                 </a:solidFill>
@@ -9280,7 +9280,7 @@
               <a:buNone/>
             </a:pPr>
             <a:r>
-              <a:rPr lang="en-US" sz="1200" dirty="0">
+              <a:rPr lang="en-US" sz="1100" dirty="0">
                 <a:solidFill>
                   <a:srgbClr val="276749"/>
                 </a:solidFill>
@@ -9295,7 +9295,7 @@
               <a:buNone/>
             </a:pPr>
             <a:r>
-              <a:rPr lang="en-US" sz="1200" dirty="0">
+              <a:rPr lang="en-US" sz="1100" dirty="0">
                 <a:solidFill>
                   <a:srgbClr val="C53030"/>
                 </a:solidFill>
@@ -9309,7 +9309,7 @@
               <a:buNone/>
             </a:pPr>
             <a:r>
-              <a:rPr lang="en-US" sz="1200" dirty="0">
+              <a:rPr lang="en-US" sz="1100" dirty="0">
                 <a:solidFill>
                   <a:srgbClr val="276749"/>
                 </a:solidFill>
@@ -9324,7 +9324,7 @@
               <a:buNone/>
             </a:pPr>
             <a:r>
-              <a:rPr lang="en-US" sz="1200" dirty="0">
+              <a:rPr lang="en-US" sz="1100" dirty="0">
                 <a:solidFill>
                   <a:srgbClr val="1A1A1A"/>
                 </a:solidFill>
@@ -9339,7 +9339,7 @@
               <a:buNone/>
             </a:pPr>
             <a:r>
-              <a:rPr lang="en-US" sz="1200" dirty="0">
+              <a:rPr lang="en-US" sz="1100" dirty="0">
                 <a:solidFill>
                   <a:srgbClr val="C53030"/>
                 </a:solidFill>
@@ -9353,7 +9353,7 @@
               <a:buNone/>
             </a:pPr>
             <a:r>
-              <a:rPr lang="en-US" sz="1200" dirty="0">
+              <a:rPr lang="en-US" sz="1100" dirty="0">
                 <a:solidFill>
                   <a:srgbClr val="276749"/>
                 </a:solidFill>
@@ -9367,7 +9367,7 @@
               <a:buNone/>
             </a:pPr>
             <a:r>
-              <a:rPr lang="en-US" sz="1200" dirty="0">
+              <a:rPr lang="en-US" sz="1100" dirty="0">
                 <a:solidFill>
                   <a:srgbClr val="6E7681"/>
                 </a:solidFill>
@@ -9382,7 +9382,7 @@
               <a:buNone/>
             </a:pPr>
             <a:r>
-              <a:rPr lang="en-US" sz="1200" dirty="0">
+              <a:rPr lang="en-US" sz="1100" dirty="0">
                 <a:solidFill>
                   <a:srgbClr val="C53030"/>
                 </a:solidFill>
@@ -9396,7 +9396,7 @@
               <a:buNone/>
             </a:pPr>
             <a:r>
-              <a:rPr lang="en-US" sz="1200" dirty="0">
+              <a:rPr lang="en-US" sz="1100" dirty="0">
                 <a:solidFill>
                   <a:srgbClr val="276749"/>
                 </a:solidFill>
@@ -9410,7 +9410,7 @@
               <a:buNone/>
             </a:pPr>
             <a:r>
-              <a:rPr lang="en-US" sz="1200" dirty="0">
+              <a:rPr lang="en-US" sz="1100" dirty="0">
                 <a:solidFill>
                   <a:srgbClr val="6E7681"/>
                 </a:solidFill>
@@ -9425,7 +9425,7 @@
               <a:buNone/>
             </a:pPr>
             <a:r>
-              <a:rPr lang="en-US" sz="1200" dirty="0">
+              <a:rPr lang="en-US" sz="1100" dirty="0">
                 <a:solidFill>
                   <a:srgbClr val="C53030"/>
                 </a:solidFill>
@@ -9439,7 +9439,7 @@
               <a:buNone/>
             </a:pPr>
             <a:r>
-              <a:rPr lang="en-US" sz="1200" dirty="0">
+              <a:rPr lang="en-US" sz="1100" dirty="0">
                 <a:solidFill>
                   <a:srgbClr val="276749"/>
                 </a:solidFill>
@@ -9453,7 +9453,7 @@
               <a:buNone/>
             </a:pPr>
             <a:r>
-              <a:rPr lang="en-US" sz="1200" dirty="0">
+              <a:rPr lang="en-US" sz="1100" dirty="0">
                 <a:solidFill>
                   <a:srgbClr val="6E7681"/>
                 </a:solidFill>
@@ -9468,7 +9468,7 @@
               <a:buNone/>
             </a:pPr>
             <a:r>
-              <a:rPr lang="en-US" sz="1200" dirty="0">
+              <a:rPr lang="en-US" sz="1100" dirty="0">
                 <a:solidFill>
                   <a:srgbClr val="C53030"/>
                 </a:solidFill>
@@ -9482,7 +9482,7 @@
               <a:buNone/>
             </a:pPr>
             <a:r>
-              <a:rPr lang="en-US" sz="1200" dirty="0">
+              <a:rPr lang="en-US" sz="1100" dirty="0">
                 <a:solidFill>
                   <a:srgbClr val="276749"/>
                 </a:solidFill>
@@ -9496,7 +9496,7 @@
               <a:buNone/>
             </a:pPr>
             <a:r>
-              <a:rPr lang="en-US" sz="1200" dirty="0">
+              <a:rPr lang="en-US" sz="1100" dirty="0">
                 <a:solidFill>
                   <a:srgbClr val="6E7681"/>
                 </a:solidFill>
@@ -9511,7 +9511,7 @@
               <a:buNone/>
             </a:pPr>
             <a:r>
-              <a:rPr lang="en-US" sz="1200" dirty="0">
+              <a:rPr lang="en-US" sz="1100" dirty="0">
                 <a:solidFill>
                   <a:srgbClr val="1A1A1A"/>
                 </a:solidFill>
@@ -9523,7 +9523,7 @@
 }
 </a:t>
             </a:r>
-            <a:endParaRPr lang="en-US" sz="1200" dirty="0"/>
+            <a:endParaRPr lang="en-US" sz="1100" dirty="0"/>
           </a:p>
         </p:txBody>
       </p:sp>
@@ -9535,7 +9535,7 @@
         </p:nvSpPr>
         <p:spPr>
           <a:xfrm>
-            <a:off x="7406640" y="3657600"/>
+            <a:off x="7406640" y="3520440"/>
             <a:ext cx="4114800" cy="365760"/>
           </a:xfrm>
           <a:prstGeom prst="rect">
@@ -9574,8 +9574,8 @@
         </p:nvSpPr>
         <p:spPr>
           <a:xfrm>
-            <a:off x="7406640" y="4114800"/>
-            <a:ext cx="4114800" cy="2377440"/>
+            <a:off x="7406640" y="3977640"/>
+            <a:ext cx="4114800" cy="2743200"/>
           </a:xfrm>
           <a:prstGeom prst="rect">
             <a:avLst/>

</xml_diff>